<commit_message>
docs: simplifica secao da apresentacao e ajusta dependencias
</commit_message>
<xml_diff>
--- a/apresentacao/radar_legislativo_pitch.pptx
+++ b/apresentacao/radar_legislativo_pitch.pptx
@@ -5,14 +5,14 @@
     <p:sldMasterId id="2147483648" r:id="rId1"/>
   </p:sldMasterIdLst>
   <p:sldIdLst>
-    <p:sldId id="256" r:id="rId7"/>
-    <p:sldId id="257" r:id="rId8"/>
-    <p:sldId id="258" r:id="rId9"/>
-    <p:sldId id="259" r:id="rId10"/>
-    <p:sldId id="260" r:id="rId11"/>
-    <p:sldId id="261" r:id="rId12"/>
+    <p:sldId id="256" r:id="rId2"/>
+    <p:sldId id="257" r:id="rId3"/>
+    <p:sldId id="258" r:id="rId4"/>
+    <p:sldId id="259" r:id="rId5"/>
+    <p:sldId id="260" r:id="rId6"/>
+    <p:sldId id="261" r:id="rId7"/>
   </p:sldIdLst>
-  <p:sldSz cx="12191695" cy="6858000" type="screen4x3"/>
+  <p:sldSz cx="12192000" cy="6858000"/>
   <p:notesSz cx="6858000" cy="9144000"/>
   <p:defaultTextStyle>
     <a:defPPr>
@@ -109,7 +109,31 @@
       </a:defRPr>
     </a:lvl9pPr>
   </p:defaultTextStyle>
+  <p:extLst>
+    <p:ext uri="{EFAFB233-063F-42B5-8137-9DF3F51BA10A}">
+      <p15:sldGuideLst xmlns:p15="http://schemas.microsoft.com/office/powerpoint/2012/main">
+        <p15:guide id="1" orient="horz" pos="2160">
+          <p15:clr>
+            <a:srgbClr val="A4A3A4"/>
+          </p15:clr>
+        </p15:guide>
+        <p15:guide id="2" pos="2880">
+          <p15:clr>
+            <a:srgbClr val="A4A3A4"/>
+          </p15:clr>
+        </p15:guide>
+      </p15:sldGuideLst>
+    </p:ext>
+  </p:extLst>
 </p:presentation>
+</file>
+
+<file path=ppt/revisionInfo.xml><?xml version="1.0" encoding="utf-8"?>
+<p1510:revInfo xmlns:a="http://schemas.openxmlformats.org/drawingml/2006/main" xmlns:r="http://schemas.openxmlformats.org/officeDocument/2006/relationships" xmlns:p1510="http://schemas.microsoft.com/office/powerpoint/2015/10/main">
+  <p1510:revLst>
+    <p1510:client id="{7718A81B-8D88-12AB-AB67-7A6DDE67ED02}" v="4" dt="2026-07-13T02:50:47.238"/>
+  </p1510:revLst>
+</p1510:revInfo>
 </file>
 
 <file path=ppt/slideLayouts/slideLayout1.xml><?xml version="1.0" encoding="utf-8"?>
@@ -150,10 +174,9 @@
           <a:lstStyle/>
           <a:p>
             <a:r>
-              <a:rPr lang="en-US" smtClean="0"/>
+              <a:rPr lang="en-US"/>
               <a:t>Click to edit Master title style</a:t>
             </a:r>
-            <a:endParaRPr lang="en-US"/>
           </a:p>
         </p:txBody>
       </p:sp>
@@ -269,10 +292,9 @@
           </a:lstStyle>
           <a:p>
             <a:r>
-              <a:rPr lang="en-US" smtClean="0"/>
+              <a:rPr lang="en-US"/>
               <a:t>Click to edit Master subtitle style</a:t>
             </a:r>
-            <a:endParaRPr lang="en-US"/>
           </a:p>
         </p:txBody>
       </p:sp>
@@ -293,7 +315,7 @@
           <a:p>
             <a:fld id="{5BCAD085-E8A6-8845-BD4E-CB4CCA059FC4}" type="datetimeFigureOut">
               <a:rPr lang="en-US" smtClean="0"/>
-              <a:t>1/27/13</a:t>
+              <a:t>7/12/2026</a:t>
             </a:fld>
             <a:endParaRPr lang="en-US"/>
           </a:p>
@@ -335,7 +357,7 @@
           <a:p>
             <a:fld id="{C1FF6DA9-008F-8B48-92A6-B652298478BF}" type="slidenum">
               <a:rPr lang="en-US" smtClean="0"/>
-              <a:t>‹#›</a:t>
+              <a:t>‹nº›</a:t>
             </a:fld>
             <a:endParaRPr lang="en-US"/>
           </a:p>
@@ -387,10 +409,9 @@
           <a:lstStyle/>
           <a:p>
             <a:r>
-              <a:rPr lang="en-US" smtClean="0"/>
+              <a:rPr lang="en-US"/>
               <a:t>Click to edit Master title style</a:t>
             </a:r>
-            <a:endParaRPr lang="en-US"/>
           </a:p>
         </p:txBody>
       </p:sp>
@@ -411,38 +432,37 @@
           <a:p>
             <a:pPr lvl="0"/>
             <a:r>
-              <a:rPr lang="en-US" smtClean="0"/>
+              <a:rPr lang="en-US"/>
               <a:t>Click to edit Master text styles</a:t>
             </a:r>
           </a:p>
           <a:p>
             <a:pPr lvl="1"/>
             <a:r>
-              <a:rPr lang="en-US" smtClean="0"/>
+              <a:rPr lang="en-US"/>
               <a:t>Second level</a:t>
             </a:r>
           </a:p>
           <a:p>
             <a:pPr lvl="2"/>
             <a:r>
-              <a:rPr lang="en-US" smtClean="0"/>
+              <a:rPr lang="en-US"/>
               <a:t>Third level</a:t>
             </a:r>
           </a:p>
           <a:p>
             <a:pPr lvl="3"/>
             <a:r>
-              <a:rPr lang="en-US" smtClean="0"/>
+              <a:rPr lang="en-US"/>
               <a:t>Fourth level</a:t>
             </a:r>
           </a:p>
           <a:p>
             <a:pPr lvl="4"/>
             <a:r>
-              <a:rPr lang="en-US" smtClean="0"/>
+              <a:rPr lang="en-US"/>
               <a:t>Fifth level</a:t>
             </a:r>
-            <a:endParaRPr lang="en-US"/>
           </a:p>
         </p:txBody>
       </p:sp>
@@ -463,7 +483,7 @@
           <a:p>
             <a:fld id="{5BCAD085-E8A6-8845-BD4E-CB4CCA059FC4}" type="datetimeFigureOut">
               <a:rPr lang="en-US" smtClean="0"/>
-              <a:t>1/27/13</a:t>
+              <a:t>7/12/2026</a:t>
             </a:fld>
             <a:endParaRPr lang="en-US"/>
           </a:p>
@@ -505,7 +525,7 @@
           <a:p>
             <a:fld id="{C1FF6DA9-008F-8B48-92A6-B652298478BF}" type="slidenum">
               <a:rPr lang="en-US" smtClean="0"/>
-              <a:t>‹#›</a:t>
+              <a:t>‹nº›</a:t>
             </a:fld>
             <a:endParaRPr lang="en-US"/>
           </a:p>
@@ -562,10 +582,9 @@
           <a:lstStyle/>
           <a:p>
             <a:r>
-              <a:rPr lang="en-US" smtClean="0"/>
+              <a:rPr lang="en-US"/>
               <a:t>Click to edit Master title style</a:t>
             </a:r>
-            <a:endParaRPr lang="en-US"/>
           </a:p>
         </p:txBody>
       </p:sp>
@@ -591,38 +610,37 @@
           <a:p>
             <a:pPr lvl="0"/>
             <a:r>
-              <a:rPr lang="en-US" smtClean="0"/>
+              <a:rPr lang="en-US"/>
               <a:t>Click to edit Master text styles</a:t>
             </a:r>
           </a:p>
           <a:p>
             <a:pPr lvl="1"/>
             <a:r>
-              <a:rPr lang="en-US" smtClean="0"/>
+              <a:rPr lang="en-US"/>
               <a:t>Second level</a:t>
             </a:r>
           </a:p>
           <a:p>
             <a:pPr lvl="2"/>
             <a:r>
-              <a:rPr lang="en-US" smtClean="0"/>
+              <a:rPr lang="en-US"/>
               <a:t>Third level</a:t>
             </a:r>
           </a:p>
           <a:p>
             <a:pPr lvl="3"/>
             <a:r>
-              <a:rPr lang="en-US" smtClean="0"/>
+              <a:rPr lang="en-US"/>
               <a:t>Fourth level</a:t>
             </a:r>
           </a:p>
           <a:p>
             <a:pPr lvl="4"/>
             <a:r>
-              <a:rPr lang="en-US" smtClean="0"/>
+              <a:rPr lang="en-US"/>
               <a:t>Fifth level</a:t>
             </a:r>
-            <a:endParaRPr lang="en-US"/>
           </a:p>
         </p:txBody>
       </p:sp>
@@ -643,7 +661,7 @@
           <a:p>
             <a:fld id="{5BCAD085-E8A6-8845-BD4E-CB4CCA059FC4}" type="datetimeFigureOut">
               <a:rPr lang="en-US" smtClean="0"/>
-              <a:t>1/27/13</a:t>
+              <a:t>7/12/2026</a:t>
             </a:fld>
             <a:endParaRPr lang="en-US"/>
           </a:p>
@@ -685,7 +703,7 @@
           <a:p>
             <a:fld id="{C1FF6DA9-008F-8B48-92A6-B652298478BF}" type="slidenum">
               <a:rPr lang="en-US" smtClean="0"/>
-              <a:t>‹#›</a:t>
+              <a:t>‹nº›</a:t>
             </a:fld>
             <a:endParaRPr lang="en-US"/>
           </a:p>
@@ -737,10 +755,9 @@
           <a:lstStyle/>
           <a:p>
             <a:r>
-              <a:rPr lang="en-US" smtClean="0"/>
+              <a:rPr lang="en-US"/>
               <a:t>Click to edit Master title style</a:t>
             </a:r>
-            <a:endParaRPr lang="en-US"/>
           </a:p>
         </p:txBody>
       </p:sp>
@@ -761,38 +778,37 @@
           <a:p>
             <a:pPr lvl="0"/>
             <a:r>
-              <a:rPr lang="en-US" smtClean="0"/>
+              <a:rPr lang="en-US"/>
               <a:t>Click to edit Master text styles</a:t>
             </a:r>
           </a:p>
           <a:p>
             <a:pPr lvl="1"/>
             <a:r>
-              <a:rPr lang="en-US" smtClean="0"/>
+              <a:rPr lang="en-US"/>
               <a:t>Second level</a:t>
             </a:r>
           </a:p>
           <a:p>
             <a:pPr lvl="2"/>
             <a:r>
-              <a:rPr lang="en-US" smtClean="0"/>
+              <a:rPr lang="en-US"/>
               <a:t>Third level</a:t>
             </a:r>
           </a:p>
           <a:p>
             <a:pPr lvl="3"/>
             <a:r>
-              <a:rPr lang="en-US" smtClean="0"/>
+              <a:rPr lang="en-US"/>
               <a:t>Fourth level</a:t>
             </a:r>
           </a:p>
           <a:p>
             <a:pPr lvl="4"/>
             <a:r>
-              <a:rPr lang="en-US" smtClean="0"/>
+              <a:rPr lang="en-US"/>
               <a:t>Fifth level</a:t>
             </a:r>
-            <a:endParaRPr lang="en-US"/>
           </a:p>
         </p:txBody>
       </p:sp>
@@ -813,7 +829,7 @@
           <a:p>
             <a:fld id="{5BCAD085-E8A6-8845-BD4E-CB4CCA059FC4}" type="datetimeFigureOut">
               <a:rPr lang="en-US" smtClean="0"/>
-              <a:t>1/27/13</a:t>
+              <a:t>7/12/2026</a:t>
             </a:fld>
             <a:endParaRPr lang="en-US"/>
           </a:p>
@@ -855,7 +871,7 @@
           <a:p>
             <a:fld id="{C1FF6DA9-008F-8B48-92A6-B652298478BF}" type="slidenum">
               <a:rPr lang="en-US" smtClean="0"/>
-              <a:t>‹#›</a:t>
+              <a:t>‹nº›</a:t>
             </a:fld>
             <a:endParaRPr lang="en-US"/>
           </a:p>
@@ -916,10 +932,9 @@
           </a:lstStyle>
           <a:p>
             <a:r>
-              <a:rPr lang="en-US" smtClean="0"/>
+              <a:rPr lang="en-US"/>
               <a:t>Click to edit Master title style</a:t>
             </a:r>
-            <a:endParaRPr lang="en-US"/>
           </a:p>
         </p:txBody>
       </p:sp>
@@ -1036,7 +1051,7 @@
           <a:p>
             <a:pPr lvl="0"/>
             <a:r>
-              <a:rPr lang="en-US" smtClean="0"/>
+              <a:rPr lang="en-US"/>
               <a:t>Click to edit Master text styles</a:t>
             </a:r>
           </a:p>
@@ -1059,7 +1074,7 @@
           <a:p>
             <a:fld id="{5BCAD085-E8A6-8845-BD4E-CB4CCA059FC4}" type="datetimeFigureOut">
               <a:rPr lang="en-US" smtClean="0"/>
-              <a:t>1/27/13</a:t>
+              <a:t>7/12/2026</a:t>
             </a:fld>
             <a:endParaRPr lang="en-US"/>
           </a:p>
@@ -1101,7 +1116,7 @@
           <a:p>
             <a:fld id="{C1FF6DA9-008F-8B48-92A6-B652298478BF}" type="slidenum">
               <a:rPr lang="en-US" smtClean="0"/>
-              <a:t>‹#›</a:t>
+              <a:t>‹nº›</a:t>
             </a:fld>
             <a:endParaRPr lang="en-US"/>
           </a:p>
@@ -1153,10 +1168,9 @@
           <a:lstStyle/>
           <a:p>
             <a:r>
-              <a:rPr lang="en-US" smtClean="0"/>
+              <a:rPr lang="en-US"/>
               <a:t>Click to edit Master title style</a:t>
             </a:r>
-            <a:endParaRPr lang="en-US"/>
           </a:p>
         </p:txBody>
       </p:sp>
@@ -1210,38 +1224,37 @@
           <a:p>
             <a:pPr lvl="0"/>
             <a:r>
-              <a:rPr lang="en-US" smtClean="0"/>
+              <a:rPr lang="en-US"/>
               <a:t>Click to edit Master text styles</a:t>
             </a:r>
           </a:p>
           <a:p>
             <a:pPr lvl="1"/>
             <a:r>
-              <a:rPr lang="en-US" smtClean="0"/>
+              <a:rPr lang="en-US"/>
               <a:t>Second level</a:t>
             </a:r>
           </a:p>
           <a:p>
             <a:pPr lvl="2"/>
             <a:r>
-              <a:rPr lang="en-US" smtClean="0"/>
+              <a:rPr lang="en-US"/>
               <a:t>Third level</a:t>
             </a:r>
           </a:p>
           <a:p>
             <a:pPr lvl="3"/>
             <a:r>
-              <a:rPr lang="en-US" smtClean="0"/>
+              <a:rPr lang="en-US"/>
               <a:t>Fourth level</a:t>
             </a:r>
           </a:p>
           <a:p>
             <a:pPr lvl="4"/>
             <a:r>
-              <a:rPr lang="en-US" smtClean="0"/>
+              <a:rPr lang="en-US"/>
               <a:t>Fifth level</a:t>
             </a:r>
-            <a:endParaRPr lang="en-US"/>
           </a:p>
         </p:txBody>
       </p:sp>
@@ -1295,38 +1308,37 @@
           <a:p>
             <a:pPr lvl="0"/>
             <a:r>
-              <a:rPr lang="en-US" smtClean="0"/>
+              <a:rPr lang="en-US"/>
               <a:t>Click to edit Master text styles</a:t>
             </a:r>
           </a:p>
           <a:p>
             <a:pPr lvl="1"/>
             <a:r>
-              <a:rPr lang="en-US" smtClean="0"/>
+              <a:rPr lang="en-US"/>
               <a:t>Second level</a:t>
             </a:r>
           </a:p>
           <a:p>
             <a:pPr lvl="2"/>
             <a:r>
-              <a:rPr lang="en-US" smtClean="0"/>
+              <a:rPr lang="en-US"/>
               <a:t>Third level</a:t>
             </a:r>
           </a:p>
           <a:p>
             <a:pPr lvl="3"/>
             <a:r>
-              <a:rPr lang="en-US" smtClean="0"/>
+              <a:rPr lang="en-US"/>
               <a:t>Fourth level</a:t>
             </a:r>
           </a:p>
           <a:p>
             <a:pPr lvl="4"/>
             <a:r>
-              <a:rPr lang="en-US" smtClean="0"/>
+              <a:rPr lang="en-US"/>
               <a:t>Fifth level</a:t>
             </a:r>
-            <a:endParaRPr lang="en-US"/>
           </a:p>
         </p:txBody>
       </p:sp>
@@ -1347,7 +1359,7 @@
           <a:p>
             <a:fld id="{5BCAD085-E8A6-8845-BD4E-CB4CCA059FC4}" type="datetimeFigureOut">
               <a:rPr lang="en-US" smtClean="0"/>
-              <a:t>1/27/13</a:t>
+              <a:t>7/12/2026</a:t>
             </a:fld>
             <a:endParaRPr lang="en-US"/>
           </a:p>
@@ -1389,7 +1401,7 @@
           <a:p>
             <a:fld id="{C1FF6DA9-008F-8B48-92A6-B652298478BF}" type="slidenum">
               <a:rPr lang="en-US" smtClean="0"/>
-              <a:t>‹#›</a:t>
+              <a:t>‹nº›</a:t>
             </a:fld>
             <a:endParaRPr lang="en-US"/>
           </a:p>
@@ -1445,10 +1457,9 @@
           </a:lstStyle>
           <a:p>
             <a:r>
-              <a:rPr lang="en-US" smtClean="0"/>
+              <a:rPr lang="en-US"/>
               <a:t>Click to edit Master title style</a:t>
             </a:r>
-            <a:endParaRPr lang="en-US"/>
           </a:p>
         </p:txBody>
       </p:sp>
@@ -1511,7 +1522,7 @@
           <a:p>
             <a:pPr lvl="0"/>
             <a:r>
-              <a:rPr lang="en-US" smtClean="0"/>
+              <a:rPr lang="en-US"/>
               <a:t>Click to edit Master text styles</a:t>
             </a:r>
           </a:p>
@@ -1567,38 +1578,37 @@
           <a:p>
             <a:pPr lvl="0"/>
             <a:r>
-              <a:rPr lang="en-US" smtClean="0"/>
+              <a:rPr lang="en-US"/>
               <a:t>Click to edit Master text styles</a:t>
             </a:r>
           </a:p>
           <a:p>
             <a:pPr lvl="1"/>
             <a:r>
-              <a:rPr lang="en-US" smtClean="0"/>
+              <a:rPr lang="en-US"/>
               <a:t>Second level</a:t>
             </a:r>
           </a:p>
           <a:p>
             <a:pPr lvl="2"/>
             <a:r>
-              <a:rPr lang="en-US" smtClean="0"/>
+              <a:rPr lang="en-US"/>
               <a:t>Third level</a:t>
             </a:r>
           </a:p>
           <a:p>
             <a:pPr lvl="3"/>
             <a:r>
-              <a:rPr lang="en-US" smtClean="0"/>
+              <a:rPr lang="en-US"/>
               <a:t>Fourth level</a:t>
             </a:r>
           </a:p>
           <a:p>
             <a:pPr lvl="4"/>
             <a:r>
-              <a:rPr lang="en-US" smtClean="0"/>
+              <a:rPr lang="en-US"/>
               <a:t>Fifth level</a:t>
             </a:r>
-            <a:endParaRPr lang="en-US"/>
           </a:p>
         </p:txBody>
       </p:sp>
@@ -1661,7 +1671,7 @@
           <a:p>
             <a:pPr lvl="0"/>
             <a:r>
-              <a:rPr lang="en-US" smtClean="0"/>
+              <a:rPr lang="en-US"/>
               <a:t>Click to edit Master text styles</a:t>
             </a:r>
           </a:p>
@@ -1717,38 +1727,37 @@
           <a:p>
             <a:pPr lvl="0"/>
             <a:r>
-              <a:rPr lang="en-US" smtClean="0"/>
+              <a:rPr lang="en-US"/>
               <a:t>Click to edit Master text styles</a:t>
             </a:r>
           </a:p>
           <a:p>
             <a:pPr lvl="1"/>
             <a:r>
-              <a:rPr lang="en-US" smtClean="0"/>
+              <a:rPr lang="en-US"/>
               <a:t>Second level</a:t>
             </a:r>
           </a:p>
           <a:p>
             <a:pPr lvl="2"/>
             <a:r>
-              <a:rPr lang="en-US" smtClean="0"/>
+              <a:rPr lang="en-US"/>
               <a:t>Third level</a:t>
             </a:r>
           </a:p>
           <a:p>
             <a:pPr lvl="3"/>
             <a:r>
-              <a:rPr lang="en-US" smtClean="0"/>
+              <a:rPr lang="en-US"/>
               <a:t>Fourth level</a:t>
             </a:r>
           </a:p>
           <a:p>
             <a:pPr lvl="4"/>
             <a:r>
-              <a:rPr lang="en-US" smtClean="0"/>
+              <a:rPr lang="en-US"/>
               <a:t>Fifth level</a:t>
             </a:r>
-            <a:endParaRPr lang="en-US"/>
           </a:p>
         </p:txBody>
       </p:sp>
@@ -1769,7 +1778,7 @@
           <a:p>
             <a:fld id="{5BCAD085-E8A6-8845-BD4E-CB4CCA059FC4}" type="datetimeFigureOut">
               <a:rPr lang="en-US" smtClean="0"/>
-              <a:t>1/27/13</a:t>
+              <a:t>7/12/2026</a:t>
             </a:fld>
             <a:endParaRPr lang="en-US"/>
           </a:p>
@@ -1811,7 +1820,7 @@
           <a:p>
             <a:fld id="{C1FF6DA9-008F-8B48-92A6-B652298478BF}" type="slidenum">
               <a:rPr lang="en-US" smtClean="0"/>
-              <a:t>‹#›</a:t>
+              <a:t>‹nº›</a:t>
             </a:fld>
             <a:endParaRPr lang="en-US"/>
           </a:p>
@@ -1863,10 +1872,9 @@
           <a:lstStyle/>
           <a:p>
             <a:r>
-              <a:rPr lang="en-US" smtClean="0"/>
+              <a:rPr lang="en-US"/>
               <a:t>Click to edit Master title style</a:t>
             </a:r>
-            <a:endParaRPr lang="en-US"/>
           </a:p>
         </p:txBody>
       </p:sp>
@@ -1887,7 +1895,7 @@
           <a:p>
             <a:fld id="{5BCAD085-E8A6-8845-BD4E-CB4CCA059FC4}" type="datetimeFigureOut">
               <a:rPr lang="en-US" smtClean="0"/>
-              <a:t>1/27/13</a:t>
+              <a:t>7/12/2026</a:t>
             </a:fld>
             <a:endParaRPr lang="en-US"/>
           </a:p>
@@ -1929,7 +1937,7 @@
           <a:p>
             <a:fld id="{C1FF6DA9-008F-8B48-92A6-B652298478BF}" type="slidenum">
               <a:rPr lang="en-US" smtClean="0"/>
-              <a:t>‹#›</a:t>
+              <a:t>‹nº›</a:t>
             </a:fld>
             <a:endParaRPr lang="en-US"/>
           </a:p>
@@ -1982,7 +1990,7 @@
           <a:p>
             <a:fld id="{5BCAD085-E8A6-8845-BD4E-CB4CCA059FC4}" type="datetimeFigureOut">
               <a:rPr lang="en-US" smtClean="0"/>
-              <a:t>1/27/13</a:t>
+              <a:t>7/12/2026</a:t>
             </a:fld>
             <a:endParaRPr lang="en-US"/>
           </a:p>
@@ -2024,7 +2032,7 @@
           <a:p>
             <a:fld id="{C1FF6DA9-008F-8B48-92A6-B652298478BF}" type="slidenum">
               <a:rPr lang="en-US" smtClean="0"/>
-              <a:t>‹#›</a:t>
+              <a:t>‹nº›</a:t>
             </a:fld>
             <a:endParaRPr lang="en-US"/>
           </a:p>
@@ -2085,10 +2093,9 @@
           </a:lstStyle>
           <a:p>
             <a:r>
-              <a:rPr lang="en-US" smtClean="0"/>
+              <a:rPr lang="en-US"/>
               <a:t>Click to edit Master title style</a:t>
             </a:r>
-            <a:endParaRPr lang="en-US"/>
           </a:p>
         </p:txBody>
       </p:sp>
@@ -2142,38 +2149,37 @@
           <a:p>
             <a:pPr lvl="0"/>
             <a:r>
-              <a:rPr lang="en-US" smtClean="0"/>
+              <a:rPr lang="en-US"/>
               <a:t>Click to edit Master text styles</a:t>
             </a:r>
           </a:p>
           <a:p>
             <a:pPr lvl="1"/>
             <a:r>
-              <a:rPr lang="en-US" smtClean="0"/>
+              <a:rPr lang="en-US"/>
               <a:t>Second level</a:t>
             </a:r>
           </a:p>
           <a:p>
             <a:pPr lvl="2"/>
             <a:r>
-              <a:rPr lang="en-US" smtClean="0"/>
+              <a:rPr lang="en-US"/>
               <a:t>Third level</a:t>
             </a:r>
           </a:p>
           <a:p>
             <a:pPr lvl="3"/>
             <a:r>
-              <a:rPr lang="en-US" smtClean="0"/>
+              <a:rPr lang="en-US"/>
               <a:t>Fourth level</a:t>
             </a:r>
           </a:p>
           <a:p>
             <a:pPr lvl="4"/>
             <a:r>
-              <a:rPr lang="en-US" smtClean="0"/>
+              <a:rPr lang="en-US"/>
               <a:t>Fifth level</a:t>
             </a:r>
-            <a:endParaRPr lang="en-US"/>
           </a:p>
         </p:txBody>
       </p:sp>
@@ -2236,7 +2242,7 @@
           <a:p>
             <a:pPr lvl="0"/>
             <a:r>
-              <a:rPr lang="en-US" smtClean="0"/>
+              <a:rPr lang="en-US"/>
               <a:t>Click to edit Master text styles</a:t>
             </a:r>
           </a:p>
@@ -2259,7 +2265,7 @@
           <a:p>
             <a:fld id="{5BCAD085-E8A6-8845-BD4E-CB4CCA059FC4}" type="datetimeFigureOut">
               <a:rPr lang="en-US" smtClean="0"/>
-              <a:t>1/27/13</a:t>
+              <a:t>7/12/2026</a:t>
             </a:fld>
             <a:endParaRPr lang="en-US"/>
           </a:p>
@@ -2301,7 +2307,7 @@
           <a:p>
             <a:fld id="{C1FF6DA9-008F-8B48-92A6-B652298478BF}" type="slidenum">
               <a:rPr lang="en-US" smtClean="0"/>
-              <a:t>‹#›</a:t>
+              <a:t>‹nº›</a:t>
             </a:fld>
             <a:endParaRPr lang="en-US"/>
           </a:p>
@@ -2362,10 +2368,9 @@
           </a:lstStyle>
           <a:p>
             <a:r>
-              <a:rPr lang="en-US" smtClean="0"/>
+              <a:rPr lang="en-US"/>
               <a:t>Click to edit Master title style</a:t>
             </a:r>
-            <a:endParaRPr lang="en-US"/>
           </a:p>
         </p:txBody>
       </p:sp>
@@ -2489,7 +2494,7 @@
           <a:p>
             <a:pPr lvl="0"/>
             <a:r>
-              <a:rPr lang="en-US" smtClean="0"/>
+              <a:rPr lang="en-US"/>
               <a:t>Click to edit Master text styles</a:t>
             </a:r>
           </a:p>
@@ -2512,7 +2517,7 @@
           <a:p>
             <a:fld id="{5BCAD085-E8A6-8845-BD4E-CB4CCA059FC4}" type="datetimeFigureOut">
               <a:rPr lang="en-US" smtClean="0"/>
-              <a:t>1/27/13</a:t>
+              <a:t>7/12/2026</a:t>
             </a:fld>
             <a:endParaRPr lang="en-US"/>
           </a:p>
@@ -2554,7 +2559,7 @@
           <a:p>
             <a:fld id="{C1FF6DA9-008F-8B48-92A6-B652298478BF}" type="slidenum">
               <a:rPr lang="en-US" smtClean="0"/>
-              <a:t>‹#›</a:t>
+              <a:t>‹nº›</a:t>
             </a:fld>
             <a:endParaRPr lang="en-US"/>
           </a:p>
@@ -2621,10 +2626,9 @@
           <a:lstStyle/>
           <a:p>
             <a:r>
-              <a:rPr lang="en-US" smtClean="0"/>
+              <a:rPr lang="en-US"/>
               <a:t>Click to edit Master title style</a:t>
             </a:r>
-            <a:endParaRPr lang="en-US"/>
           </a:p>
         </p:txBody>
       </p:sp>
@@ -2655,38 +2659,37 @@
           <a:p>
             <a:pPr lvl="0"/>
             <a:r>
-              <a:rPr lang="en-US" smtClean="0"/>
+              <a:rPr lang="en-US"/>
               <a:t>Click to edit Master text styles</a:t>
             </a:r>
           </a:p>
           <a:p>
             <a:pPr lvl="1"/>
             <a:r>
-              <a:rPr lang="en-US" smtClean="0"/>
+              <a:rPr lang="en-US"/>
               <a:t>Second level</a:t>
             </a:r>
           </a:p>
           <a:p>
             <a:pPr lvl="2"/>
             <a:r>
-              <a:rPr lang="en-US" smtClean="0"/>
+              <a:rPr lang="en-US"/>
               <a:t>Third level</a:t>
             </a:r>
           </a:p>
           <a:p>
             <a:pPr lvl="3"/>
             <a:r>
-              <a:rPr lang="en-US" smtClean="0"/>
+              <a:rPr lang="en-US"/>
               <a:t>Fourth level</a:t>
             </a:r>
           </a:p>
           <a:p>
             <a:pPr lvl="4"/>
             <a:r>
-              <a:rPr lang="en-US" smtClean="0"/>
+              <a:rPr lang="en-US"/>
               <a:t>Fifth level</a:t>
             </a:r>
-            <a:endParaRPr lang="en-US"/>
           </a:p>
         </p:txBody>
       </p:sp>
@@ -2725,7 +2728,7 @@
           <a:p>
             <a:fld id="{5BCAD085-E8A6-8845-BD4E-CB4CCA059FC4}" type="datetimeFigureOut">
               <a:rPr lang="en-US" smtClean="0"/>
-              <a:t>1/27/13</a:t>
+              <a:t>7/12/2026</a:t>
             </a:fld>
             <a:endParaRPr lang="en-US"/>
           </a:p>
@@ -2803,7 +2806,7 @@
           <a:p>
             <a:fld id="{C1FF6DA9-008F-8B48-92A6-B652298478BF}" type="slidenum">
               <a:rPr lang="en-US" smtClean="0"/>
-              <a:t>‹#›</a:t>
+              <a:t>‹nº›</a:t>
             </a:fld>
             <a:endParaRPr lang="en-US"/>
           </a:p>
@@ -3084,7 +3087,7 @@
 </file>
 
 <file path=ppt/slides/slide1.xml><?xml version="1.0" encoding="utf-8"?>
-<p:sld xmlns:a="http://schemas.openxmlformats.org/drawingml/2006/main" xmlns:p="http://schemas.openxmlformats.org/presentationml/2006/main" xmlns:r="http://schemas.openxmlformats.org/officeDocument/2006/relationships">
+<p:sld xmlns:a="http://schemas.openxmlformats.org/drawingml/2006/main" xmlns:r="http://schemas.openxmlformats.org/officeDocument/2006/relationships" xmlns:p="http://schemas.openxmlformats.org/presentationml/2006/main">
   <p:cSld>
     <p:bg>
       <p:bgPr>
@@ -3100,7 +3103,14 @@
         <p:cNvGrpSpPr/>
         <p:nvPr/>
       </p:nvGrpSpPr>
-      <p:grpSpPr/>
+      <p:grpSpPr>
+        <a:xfrm>
+          <a:off x="0" y="0"/>
+          <a:ext cx="0" cy="0"/>
+          <a:chOff x="0" y="0"/>
+          <a:chExt cx="0" cy="0"/>
+        </a:xfrm>
+      </p:grpSpPr>
       <p:sp>
         <p:nvSpPr>
           <p:cNvPr id="2" name="TextBox 1"/>
@@ -3163,7 +3173,7 @@
         <p:spPr>
           <a:xfrm>
             <a:off x="731520" y="2377440"/>
-            <a:ext cx="10698480" cy="457200"/>
+            <a:ext cx="10698480" cy="369332"/>
           </a:xfrm>
           <a:prstGeom prst="rect">
             <a:avLst/>
@@ -3171,12 +3181,12 @@
           <a:noFill/>
         </p:spPr>
         <p:txBody>
-          <a:bodyPr wrap="square">
+          <a:bodyPr wrap="square" lIns="91440" tIns="45720" rIns="91440" bIns="45720" anchor="t">
             <a:spAutoFit/>
           </a:bodyPr>
           <a:lstStyle/>
           <a:p>
-            <a:pPr algn="l">
+            <a:pPr>
               <a:spcBef>
                 <a:spcPts val="600"/>
               </a:spcBef>
@@ -3189,6 +3199,11 @@
             <a:r>
               <a:t>O PROBLEMA</a:t>
             </a:r>
+            <a:r>
+              <a:rPr lang="pt-BR" dirty="0"/>
+              <a:t> </a:t>
+            </a:r>
+            <a:endParaRPr dirty="0"/>
           </a:p>
         </p:txBody>
       </p:sp>
@@ -3230,7 +3245,7 @@
           </a:fontRef>
         </p:style>
         <p:txBody>
-          <a:bodyPr rtlCol="0" anchor="ctr" wrap="square" lIns="182880" rIns="182880"/>
+          <a:bodyPr wrap="square" lIns="182880" rIns="182880" rtlCol="0" anchor="ctr"/>
           <a:lstStyle/>
           <a:p>
             <a:pPr algn="l">
@@ -3302,7 +3317,7 @@
           </a:fontRef>
         </p:style>
         <p:txBody>
-          <a:bodyPr rtlCol="0" anchor="ctr" wrap="square" lIns="182880" rIns="182880"/>
+          <a:bodyPr wrap="square" lIns="182880" rIns="182880" rtlCol="0" anchor="ctr"/>
           <a:lstStyle/>
           <a:p>
             <a:pPr algn="l">
@@ -3374,7 +3389,7 @@
           </a:fontRef>
         </p:style>
         <p:txBody>
-          <a:bodyPr rtlCol="0" anchor="ctr" wrap="square" lIns="182880" rIns="182880"/>
+          <a:bodyPr wrap="square" lIns="182880" rIns="182880" rtlCol="0" anchor="ctr"/>
           <a:lstStyle/>
           <a:p>
             <a:pPr algn="l">
@@ -3446,7 +3461,7 @@
           </a:fontRef>
         </p:style>
         <p:txBody>
-          <a:bodyPr rtlCol="0" anchor="ctr" wrap="square" lIns="182880" rIns="182880"/>
+          <a:bodyPr wrap="square" lIns="182880" rIns="182880" rtlCol="0" anchor="ctr"/>
           <a:lstStyle/>
           <a:p>
             <a:pPr algn="l">
@@ -3527,7 +3542,7 @@
 </file>
 
 <file path=ppt/slides/slide2.xml><?xml version="1.0" encoding="utf-8"?>
-<p:sld xmlns:a="http://schemas.openxmlformats.org/drawingml/2006/main" xmlns:p="http://schemas.openxmlformats.org/presentationml/2006/main" xmlns:r="http://schemas.openxmlformats.org/officeDocument/2006/relationships">
+<p:sld xmlns:a="http://schemas.openxmlformats.org/drawingml/2006/main" xmlns:r="http://schemas.openxmlformats.org/officeDocument/2006/relationships" xmlns:p="http://schemas.openxmlformats.org/presentationml/2006/main">
   <p:cSld>
     <p:bg>
       <p:bgPr>
@@ -3543,7 +3558,14 @@
         <p:cNvGrpSpPr/>
         <p:nvPr/>
       </p:nvGrpSpPr>
-      <p:grpSpPr/>
+      <p:grpSpPr>
+        <a:xfrm>
+          <a:off x="0" y="0"/>
+          <a:ext cx="0" cy="0"/>
+          <a:chOff x="0" y="0"/>
+          <a:chExt cx="0" cy="0"/>
+        </a:xfrm>
+      </p:grpSpPr>
       <p:sp>
         <p:nvSpPr>
           <p:cNvPr id="2" name="Rectangle 1"/>
@@ -3580,7 +3602,7 @@
           </a:fontRef>
         </p:style>
         <p:txBody>
-          <a:bodyPr rtlCol="0" anchor="ctr" lIns="457200"/>
+          <a:bodyPr lIns="457200" rtlCol="0" anchor="ctr"/>
           <a:lstStyle/>
           <a:p>
             <a:pPr algn="l">
@@ -3652,7 +3674,7 @@
           </a:fontRef>
         </p:style>
         <p:txBody>
-          <a:bodyPr rtlCol="0" anchor="ctr" wrap="square" lIns="228600" rIns="228600"/>
+          <a:bodyPr wrap="square" lIns="228600" rIns="228600" rtlCol="0" anchor="ctr"/>
           <a:lstStyle/>
           <a:p>
             <a:pPr algn="l">
@@ -3724,7 +3746,7 @@
           </a:fontRef>
         </p:style>
         <p:txBody>
-          <a:bodyPr rtlCol="0" anchor="ctr" wrap="square" lIns="228600" rIns="228600"/>
+          <a:bodyPr wrap="square" lIns="228600" rIns="228600" rtlCol="0" anchor="ctr"/>
           <a:lstStyle/>
           <a:p>
             <a:pPr algn="l">
@@ -3796,7 +3818,7 @@
           </a:fontRef>
         </p:style>
         <p:txBody>
-          <a:bodyPr rtlCol="0" anchor="ctr" wrap="square" lIns="228600" rIns="228600"/>
+          <a:bodyPr wrap="square" lIns="228600" rIns="228600" rtlCol="0" anchor="ctr"/>
           <a:lstStyle/>
           <a:p>
             <a:pPr algn="l">
@@ -3868,7 +3890,7 @@
           </a:fontRef>
         </p:style>
         <p:txBody>
-          <a:bodyPr rtlCol="0" anchor="ctr" wrap="square" lIns="228600" rIns="228600"/>
+          <a:bodyPr wrap="square" lIns="228600" rIns="228600" rtlCol="0" anchor="ctr"/>
           <a:lstStyle/>
           <a:p>
             <a:pPr algn="l">
@@ -3949,7 +3971,7 @@
 </file>
 
 <file path=ppt/slides/slide3.xml><?xml version="1.0" encoding="utf-8"?>
-<p:sld xmlns:a="http://schemas.openxmlformats.org/drawingml/2006/main" xmlns:p="http://schemas.openxmlformats.org/presentationml/2006/main" xmlns:r="http://schemas.openxmlformats.org/officeDocument/2006/relationships">
+<p:sld xmlns:a="http://schemas.openxmlformats.org/drawingml/2006/main" xmlns:r="http://schemas.openxmlformats.org/officeDocument/2006/relationships" xmlns:p="http://schemas.openxmlformats.org/presentationml/2006/main">
   <p:cSld>
     <p:bg>
       <p:bgPr>
@@ -3965,7 +3987,14 @@
         <p:cNvGrpSpPr/>
         <p:nvPr/>
       </p:nvGrpSpPr>
-      <p:grpSpPr/>
+      <p:grpSpPr>
+        <a:xfrm>
+          <a:off x="0" y="0"/>
+          <a:ext cx="0" cy="0"/>
+          <a:chOff x="0" y="0"/>
+          <a:chExt cx="0" cy="0"/>
+        </a:xfrm>
+      </p:grpSpPr>
       <p:sp>
         <p:nvSpPr>
           <p:cNvPr id="2" name="Rectangle 1"/>
@@ -4002,7 +4031,7 @@
           </a:fontRef>
         </p:style>
         <p:txBody>
-          <a:bodyPr rtlCol="0" anchor="ctr" lIns="457200"/>
+          <a:bodyPr lIns="457200" rtlCol="0" anchor="ctr"/>
           <a:lstStyle/>
           <a:p>
             <a:pPr algn="l">
@@ -4074,7 +4103,7 @@
           </a:fontRef>
         </p:style>
         <p:txBody>
-          <a:bodyPr rtlCol="0" anchor="ctr" wrap="square" lIns="137160" rIns="137160"/>
+          <a:bodyPr wrap="square" lIns="137160" rIns="137160" rtlCol="0" anchor="ctr"/>
           <a:lstStyle/>
           <a:p>
             <a:pPr algn="ctr">
@@ -4163,6 +4192,7 @@
           <a:lstStyle/>
           <a:p>
             <a:pPr algn="ctr"/>
+            <a:endParaRPr/>
           </a:p>
         </p:txBody>
       </p:sp>
@@ -4204,7 +4234,7 @@
           </a:fontRef>
         </p:style>
         <p:txBody>
-          <a:bodyPr rtlCol="0" anchor="ctr" wrap="square" lIns="137160" rIns="137160"/>
+          <a:bodyPr wrap="square" lIns="137160" rIns="137160" rtlCol="0" anchor="ctr"/>
           <a:lstStyle/>
           <a:p>
             <a:pPr algn="ctr">
@@ -4293,6 +4323,7 @@
           <a:lstStyle/>
           <a:p>
             <a:pPr algn="ctr"/>
+            <a:endParaRPr/>
           </a:p>
         </p:txBody>
       </p:sp>
@@ -4334,7 +4365,7 @@
           </a:fontRef>
         </p:style>
         <p:txBody>
-          <a:bodyPr rtlCol="0" anchor="ctr" wrap="square" lIns="137160" rIns="137160"/>
+          <a:bodyPr wrap="square" lIns="137160" rIns="137160" rtlCol="0" anchor="ctr"/>
           <a:lstStyle/>
           <a:p>
             <a:pPr algn="ctr">
@@ -4423,6 +4454,7 @@
           <a:lstStyle/>
           <a:p>
             <a:pPr algn="ctr"/>
+            <a:endParaRPr/>
           </a:p>
         </p:txBody>
       </p:sp>
@@ -4464,7 +4496,7 @@
           </a:fontRef>
         </p:style>
         <p:txBody>
-          <a:bodyPr rtlCol="0" anchor="ctr" wrap="square" lIns="137160" rIns="137160"/>
+          <a:bodyPr wrap="square" lIns="137160" rIns="137160" rtlCol="0" anchor="ctr"/>
           <a:lstStyle/>
           <a:p>
             <a:pPr algn="ctr">
@@ -4553,6 +4585,7 @@
           <a:lstStyle/>
           <a:p>
             <a:pPr algn="ctr"/>
+            <a:endParaRPr/>
           </a:p>
         </p:txBody>
       </p:sp>
@@ -4594,7 +4627,7 @@
           </a:fontRef>
         </p:style>
         <p:txBody>
-          <a:bodyPr rtlCol="0" anchor="ctr" wrap="square" lIns="137160" rIns="137160"/>
+          <a:bodyPr wrap="square" lIns="137160" rIns="137160" rtlCol="0" anchor="ctr"/>
           <a:lstStyle/>
           <a:p>
             <a:pPr algn="ctr">
@@ -4696,7 +4729,7 @@
           </a:fontRef>
         </p:style>
         <p:txBody>
-          <a:bodyPr rtlCol="0" anchor="ctr" wrap="square" lIns="137160" rIns="137160"/>
+          <a:bodyPr wrap="square" lIns="137160" rIns="137160" rtlCol="0" anchor="ctr"/>
           <a:lstStyle/>
           <a:p>
             <a:pPr algn="ctr">
@@ -4800,6 +4833,7 @@
           <a:lstStyle/>
           <a:p>
             <a:pPr algn="ctr"/>
+            <a:endParaRPr/>
           </a:p>
         </p:txBody>
       </p:sp>
@@ -4843,6 +4877,7 @@
           <a:lstStyle/>
           <a:p>
             <a:pPr algn="ctr"/>
+            <a:endParaRPr/>
           </a:p>
         </p:txBody>
       </p:sp>
@@ -4884,7 +4919,7 @@
           </a:fontRef>
         </p:style>
         <p:txBody>
-          <a:bodyPr rtlCol="0" anchor="ctr" wrap="square" lIns="137160" rIns="137160"/>
+          <a:bodyPr wrap="square" lIns="137160" rIns="137160" rtlCol="0" anchor="ctr"/>
           <a:lstStyle/>
           <a:p>
             <a:pPr algn="ctr">
@@ -4971,7 +5006,7 @@
           </a:fontRef>
         </p:style>
         <p:txBody>
-          <a:bodyPr rtlCol="0" anchor="ctr" wrap="square" lIns="137160" rIns="137160"/>
+          <a:bodyPr wrap="square" lIns="137160" rIns="137160" rtlCol="0" anchor="ctr"/>
           <a:lstStyle/>
           <a:p>
             <a:pPr algn="ctr">
@@ -5060,6 +5095,7 @@
           <a:lstStyle/>
           <a:p>
             <a:pPr algn="ctr"/>
+            <a:endParaRPr/>
           </a:p>
         </p:txBody>
       </p:sp>
@@ -5072,7 +5108,7 @@
 </file>
 
 <file path=ppt/slides/slide4.xml><?xml version="1.0" encoding="utf-8"?>
-<p:sld xmlns:a="http://schemas.openxmlformats.org/drawingml/2006/main" xmlns:p="http://schemas.openxmlformats.org/presentationml/2006/main" xmlns:r="http://schemas.openxmlformats.org/officeDocument/2006/relationships">
+<p:sld xmlns:a="http://schemas.openxmlformats.org/drawingml/2006/main" xmlns:r="http://schemas.openxmlformats.org/officeDocument/2006/relationships" xmlns:p="http://schemas.openxmlformats.org/presentationml/2006/main">
   <p:cSld>
     <p:bg>
       <p:bgPr>
@@ -5088,7 +5124,14 @@
         <p:cNvGrpSpPr/>
         <p:nvPr/>
       </p:nvGrpSpPr>
-      <p:grpSpPr/>
+      <p:grpSpPr>
+        <a:xfrm>
+          <a:off x="0" y="0"/>
+          <a:ext cx="0" cy="0"/>
+          <a:chOff x="0" y="0"/>
+          <a:chExt cx="0" cy="0"/>
+        </a:xfrm>
+      </p:grpSpPr>
       <p:sp>
         <p:nvSpPr>
           <p:cNvPr id="2" name="Rectangle 1"/>
@@ -5125,7 +5168,7 @@
           </a:fontRef>
         </p:style>
         <p:txBody>
-          <a:bodyPr rtlCol="0" anchor="ctr" lIns="457200"/>
+          <a:bodyPr lIns="457200" rtlCol="0" anchor="ctr"/>
           <a:lstStyle/>
           <a:p>
             <a:pPr algn="l">
@@ -5197,7 +5240,7 @@
           </a:fontRef>
         </p:style>
         <p:txBody>
-          <a:bodyPr rtlCol="0" anchor="ctr" wrap="square" lIns="182880"/>
+          <a:bodyPr wrap="square" lIns="182880" rtlCol="0" anchor="ctr"/>
           <a:lstStyle/>
           <a:p>
             <a:pPr algn="l">
@@ -5262,7 +5305,7 @@
           </a:fontRef>
         </p:style>
         <p:txBody>
-          <a:bodyPr rtlCol="0" anchor="ctr" wrap="square" lIns="182880"/>
+          <a:bodyPr wrap="square" lIns="182880" rtlCol="0" anchor="ctr"/>
           <a:lstStyle/>
           <a:p>
             <a:pPr algn="l">
@@ -5319,7 +5362,7 @@
           </a:fontRef>
         </p:style>
         <p:txBody>
-          <a:bodyPr rtlCol="0" anchor="ctr" wrap="square" lIns="182880"/>
+          <a:bodyPr wrap="square" lIns="182880" rtlCol="0" anchor="ctr"/>
           <a:lstStyle/>
           <a:p>
             <a:pPr algn="l">
@@ -5384,7 +5427,7 @@
           </a:fontRef>
         </p:style>
         <p:txBody>
-          <a:bodyPr rtlCol="0" anchor="ctr" wrap="square" lIns="182880"/>
+          <a:bodyPr wrap="square" lIns="182880" rtlCol="0" anchor="ctr"/>
           <a:lstStyle/>
           <a:p>
             <a:pPr algn="l">
@@ -5441,7 +5484,7 @@
           </a:fontRef>
         </p:style>
         <p:txBody>
-          <a:bodyPr rtlCol="0" anchor="ctr" wrap="square" lIns="182880"/>
+          <a:bodyPr wrap="square" lIns="182880" rtlCol="0" anchor="ctr"/>
           <a:lstStyle/>
           <a:p>
             <a:pPr algn="l">
@@ -5498,7 +5541,7 @@
           </a:fontRef>
         </p:style>
         <p:txBody>
-          <a:bodyPr rtlCol="0" anchor="ctr" wrap="square" lIns="182880"/>
+          <a:bodyPr wrap="square" lIns="182880" rtlCol="0" anchor="ctr"/>
           <a:lstStyle/>
           <a:p>
             <a:pPr algn="l">
@@ -5634,7 +5677,7 @@
 </file>
 
 <file path=ppt/slides/slide5.xml><?xml version="1.0" encoding="utf-8"?>
-<p:sld xmlns:a="http://schemas.openxmlformats.org/drawingml/2006/main" xmlns:p="http://schemas.openxmlformats.org/presentationml/2006/main" xmlns:r="http://schemas.openxmlformats.org/officeDocument/2006/relationships">
+<p:sld xmlns:a="http://schemas.openxmlformats.org/drawingml/2006/main" xmlns:r="http://schemas.openxmlformats.org/officeDocument/2006/relationships" xmlns:p="http://schemas.openxmlformats.org/presentationml/2006/main">
   <p:cSld>
     <p:bg>
       <p:bgPr>
@@ -5650,7 +5693,14 @@
         <p:cNvGrpSpPr/>
         <p:nvPr/>
       </p:nvGrpSpPr>
-      <p:grpSpPr/>
+      <p:grpSpPr>
+        <a:xfrm>
+          <a:off x="0" y="0"/>
+          <a:ext cx="0" cy="0"/>
+          <a:chOff x="0" y="0"/>
+          <a:chExt cx="0" cy="0"/>
+        </a:xfrm>
+      </p:grpSpPr>
       <p:sp>
         <p:nvSpPr>
           <p:cNvPr id="2" name="Rectangle 1"/>
@@ -5687,7 +5737,7 @@
           </a:fontRef>
         </p:style>
         <p:txBody>
-          <a:bodyPr rtlCol="0" anchor="ctr" lIns="457200"/>
+          <a:bodyPr lIns="457200" rtlCol="0" anchor="ctr"/>
           <a:lstStyle/>
           <a:p>
             <a:pPr algn="l">
@@ -5937,7 +5987,7 @@
 </file>
 
 <file path=ppt/slides/slide6.xml><?xml version="1.0" encoding="utf-8"?>
-<p:sld xmlns:a="http://schemas.openxmlformats.org/drawingml/2006/main" xmlns:p="http://schemas.openxmlformats.org/presentationml/2006/main" xmlns:r="http://schemas.openxmlformats.org/officeDocument/2006/relationships">
+<p:sld xmlns:a="http://schemas.openxmlformats.org/drawingml/2006/main" xmlns:r="http://schemas.openxmlformats.org/officeDocument/2006/relationships" xmlns:p="http://schemas.openxmlformats.org/presentationml/2006/main">
   <p:cSld>
     <p:bg>
       <p:bgPr>
@@ -5953,7 +6003,14 @@
         <p:cNvGrpSpPr/>
         <p:nvPr/>
       </p:nvGrpSpPr>
-      <p:grpSpPr/>
+      <p:grpSpPr>
+        <a:xfrm>
+          <a:off x="0" y="0"/>
+          <a:ext cx="0" cy="0"/>
+          <a:chOff x="0" y="0"/>
+          <a:chExt cx="0" cy="0"/>
+        </a:xfrm>
+      </p:grpSpPr>
       <p:sp>
         <p:nvSpPr>
           <p:cNvPr id="2" name="TextBox 1"/>
@@ -6030,7 +6087,7 @@
           </a:fontRef>
         </p:style>
         <p:txBody>
-          <a:bodyPr rtlCol="0" anchor="ctr" wrap="square" lIns="228600"/>
+          <a:bodyPr wrap="square" lIns="228600" rtlCol="0" anchor="ctr"/>
           <a:lstStyle/>
           <a:p>
             <a:pPr algn="l">
@@ -6095,7 +6152,7 @@
           </a:fontRef>
         </p:style>
         <p:txBody>
-          <a:bodyPr rtlCol="0" anchor="ctr" wrap="square" lIns="228600"/>
+          <a:bodyPr wrap="square" lIns="228600" rtlCol="0" anchor="ctr"/>
           <a:lstStyle/>
           <a:p>
             <a:pPr algn="l">
@@ -6160,7 +6217,7 @@
           </a:fontRef>
         </p:style>
         <p:txBody>
-          <a:bodyPr rtlCol="0" anchor="ctr" wrap="square" lIns="228600"/>
+          <a:bodyPr wrap="square" lIns="228600" rtlCol="0" anchor="ctr"/>
           <a:lstStyle/>
           <a:p>
             <a:pPr algn="l">
@@ -6225,7 +6282,7 @@
           </a:fontRef>
         </p:style>
         <p:txBody>
-          <a:bodyPr rtlCol="0" anchor="ctr" wrap="square" lIns="228600"/>
+          <a:bodyPr wrap="square" lIns="228600" rtlCol="0" anchor="ctr"/>
           <a:lstStyle/>
           <a:p>
             <a:pPr algn="l">
@@ -6290,7 +6347,7 @@
           </a:fontRef>
         </p:style>
         <p:txBody>
-          <a:bodyPr rtlCol="0" anchor="ctr" wrap="square" lIns="228600"/>
+          <a:bodyPr wrap="square" lIns="228600" rtlCol="0" anchor="ctr"/>
           <a:lstStyle/>
           <a:p>
             <a:pPr algn="l">

</xml_diff>